<commit_message>
Mise à jour de l'analyse et des graphiques
</commit_message>
<xml_diff>
--- a/reports/profilage_clusters.pptx
+++ b/reports/profilage_clusters.pptx
@@ -5853,7 +5853,7 @@
                   <a:srgbClr val="537F9A"/>
                 </a:solidFill>
               </a:rPr>
-              <a:t>Profiling cluster</a:t>
+              <a:t>Profilage des clusters</a:t>
             </a:r>
             <a:endParaRPr dirty="0">
               <a:solidFill>
@@ -6227,7 +6227,7 @@
                 <a:latin typeface="Fira Sans Extra Condensed"/>
                 <a:sym typeface="Fira Sans Extra Condensed"/>
               </a:rPr>
-              <a:t>CHEFOUET Chetsong Ghislain Joel</a:t>
+              <a:t>CHEFOUET CHETSONG Ghislain Joël</a:t>
             </a:r>
           </a:p>
           <a:p>
@@ -6251,7 +6251,7 @@
                 <a:latin typeface="Fira Sans Extra Condensed"/>
                 <a:sym typeface="Fira Sans Extra Condensed"/>
               </a:rPr>
-              <a:t>N’GUESSAN Armand Loïc</a:t>
+              <a:t>N’GUESSAN Kouamé Kan Armand Loïc</a:t>
             </a:r>
           </a:p>
           <a:p>
@@ -6303,7 +6303,7 @@
                 </a:solidFill>
                 <a:latin typeface="Fira Sans Extra Condensed"/>
               </a:rPr>
-              <a:t>M. LALY </a:t>
+              <a:t>M. LALY</a:t>
             </a:r>
           </a:p>
         </p:txBody>
@@ -6416,7 +6416,7 @@
           <a:p>
             <a:r>
               <a:rPr lang="fr-FR" dirty="0"/>
-              <a:t>Cluster 1 : Couples jeunes, indépendants, à hauts revenus</a:t>
+              <a:t>Cluster 1 : Familles nombreuses à budget serré</a:t>
             </a:r>
           </a:p>
         </p:txBody>
@@ -6805,7 +6805,7 @@
                     <a:pPr lvl="0"/>
                     <a:r>
                       <a:rPr lang="fr-FR" dirty="0"/>
-                      <a:t>Ce sont systématiquement des parents, généralement dans des foyers de 2 à 4 personnes.</a:t>
+                      <a:t>3 sur 4 sont parents, dans des foyers de 1 à 3 personnes.</a:t>
                     </a:r>
                   </a:p>
                 </p:txBody>
@@ -6844,7 +6844,7 @@
                     <a:pPr lvl="0"/>
                     <a:r>
                       <a:rPr lang="fr-FR" dirty="0"/>
-                      <a:t>Un sous-groupe est constitué de parents isolés</a:t>
+                      <a:t>Presque toujours des enfants en bas âge, sans adolescent</a:t>
                     </a:r>
                     <a:endParaRPr dirty="0">
                       <a:latin typeface="Roboto"/>
@@ -6889,7 +6889,7 @@
                     <a:pPr lvl="0"/>
                     <a:r>
                       <a:rPr lang="fr-FR" dirty="0"/>
-                      <a:t>La majorité a au moins un adolescent à charge</a:t>
+                      <a:t>Les plus jeunes clients : 37 ans en moyenne</a:t>
                     </a:r>
                     <a:endParaRPr dirty="0">
                       <a:latin typeface="Roboto"/>
@@ -6934,7 +6934,7 @@
                     <a:pPr lvl="0"/>
                     <a:r>
                       <a:rPr lang="fr-FR" dirty="0"/>
-                      <a:t>Ils sont relativement plus âgés. </a:t>
+                      <a:t>Revenu (31 k) et dépenses (130) les plus faibles ; achètent peu</a:t>
                     </a:r>
                     <a:endParaRPr dirty="0">
                       <a:latin typeface="Roboto"/>
@@ -7527,7 +7527,7 @@
                     <a:pPr lvl="0"/>
                     <a:r>
                       <a:rPr lang="fr-FR" dirty="0"/>
-                      <a:t>Ils ne sont pas parents dans leur grande majorité.</a:t>
+                      <a:t>Tous parents, dans des foyers de 2 à 5 personnes</a:t>
                     </a:r>
                   </a:p>
                 </p:txBody>
@@ -7566,7 +7566,7 @@
                     <a:pPr lvl="0"/>
                     <a:r>
                       <a:rPr lang="fr-FR" dirty="0"/>
-                      <a:t>Composés surtout de couples (légèrement plus nombreux que les célibataires)</a:t>
+                      <a:t>Souvent un adolescent et un jeune enfant au domicile</a:t>
                     </a:r>
                   </a:p>
                 </p:txBody>
@@ -7605,7 +7605,7 @@
                     <a:pPr lvl="0"/>
                     <a:r>
                       <a:rPr lang="fr-FR" dirty="0"/>
-                      <a:t>Le ménage ne dépasse jamais 2 membres</a:t>
+                      <a:t>Les plus âgés : 49 ans en moyenne</a:t>
                     </a:r>
                   </a:p>
                 </p:txBody>
@@ -7644,7 +7644,7 @@
                     <a:pPr lvl="0"/>
                     <a:r>
                       <a:rPr lang="fr-FR" dirty="0"/>
-                      <a:t>Ce cluster couvre toutes les tranches d’âge</a:t>
+                      <a:t>Réponse la plus faible à la dernière campagne (6 %)</a:t>
                     </a:r>
                   </a:p>
                 </p:txBody>
@@ -7683,7 +7683,7 @@
                     <a:pPr lvl="0"/>
                     <a:r>
                       <a:rPr lang="fr-FR" dirty="0"/>
-                      <a:t>Il s’agit d’un groupe à revenu élevé avec des dépenses marquées.</a:t>
+                      <a:t>Revenu modeste (43 k) et dépenses faibles (127 sur 2 ans)</a:t>
                     </a:r>
                     <a:endParaRPr dirty="0">
                       <a:latin typeface="Roboto"/>
@@ -8068,7 +8068,7 @@
           <a:p>
             <a:r>
               <a:rPr lang="fr-FR" dirty="0"/>
-              <a:t>Cluster 0 : Parents matures en famille moyenne</a:t>
+              <a:t>Cluster 0 : Jeunes foyers modestes</a:t>
             </a:r>
           </a:p>
         </p:txBody>
@@ -8274,7 +8274,7 @@
           <a:p>
             <a:r>
               <a:rPr lang="fr-FR" dirty="0"/>
-              <a:t>Cluster 3 :Grandes familles traditionnelles à faibles revenus</a:t>
+              <a:t>Cluster 3 : Clients premium sans enfant</a:t>
             </a:r>
           </a:p>
         </p:txBody>
@@ -8663,7 +8663,7 @@
                     <a:pPr lvl="0"/>
                     <a:r>
                       <a:rPr lang="fr-FR" dirty="0"/>
-                      <a:t> La majorité sont des parents jeunes</a:t>
+                      <a:t>Tous parents, dans des foyers de 2 à 5 personnes</a:t>
                     </a:r>
                   </a:p>
                 </p:txBody>
@@ -8702,7 +8702,7 @@
                     <a:pPr lvl="0"/>
                     <a:r>
                       <a:rPr lang="fr-FR" dirty="0"/>
-                      <a:t>Les familles comptent 2 à 3 membres souvent avec un seul enfant .</a:t>
+                      <a:t>Le plus souvent des adolescents au domicile</a:t>
                     </a:r>
                   </a:p>
                 </p:txBody>
@@ -8741,7 +8741,7 @@
                     <a:pPr lvl="0"/>
                     <a:r>
                       <a:rPr lang="fr-FR" dirty="0"/>
-                      <a:t>Groupe plus jeune que la moyenne</a:t>
+                      <a:t>48 ans en moyenne ; revenu (60 k) et dépenses (833) élevés</a:t>
                     </a:r>
                   </a:p>
                 </p:txBody>
@@ -8780,7 +8780,7 @@
                     <a:pPr lvl="0"/>
                     <a:r>
                       <a:rPr lang="fr-FR" dirty="0"/>
-                      <a:t>Leur comportement d’achat reste modéré.</a:t>
+                      <a:t>Record d’achats en promotion (3,7) ; très actifs sur le web</a:t>
                     </a:r>
                     <a:endParaRPr dirty="0">
                       <a:latin typeface="Roboto"/>
@@ -9244,7 +9244,7 @@
                   <a:pPr lvl="0"/>
                   <a:r>
                     <a:rPr lang="fr-FR" dirty="0"/>
-                    <a:t>Composés uniquement de parents dans des familles de 2 à 5 personnes</a:t>
+                    <a:t>95 % sans enfant ; foyers de 1 à 2 personnes</a:t>
                   </a:r>
                 </a:p>
               </p:txBody>
@@ -9283,7 +9283,7 @@
                   <a:pPr lvl="0"/>
                   <a:r>
                     <a:rPr lang="fr-FR" dirty="0"/>
-                    <a:t> La plupart ont un adolescent à domicile</a:t>
+                    <a:t>46 ans en moyenne, en couple ou seuls</a:t>
                   </a:r>
                 </a:p>
               </p:txBody>
@@ -9322,7 +9322,7 @@
                   <a:pPr lvl="0"/>
                   <a:r>
                     <a:rPr lang="fr-FR" dirty="0"/>
-                    <a:t> Malgré des revenus modestes, leur engagement dans certaines offres est élevé. </a:t>
+                    <a:t>Peu d’achats en promotion, mais le plus de campagnes acceptées</a:t>
                   </a:r>
                   <a:endParaRPr dirty="0">
                     <a:latin typeface="Roboto"/>
@@ -9367,7 +9367,7 @@
                   <a:pPr lvl="0"/>
                   <a:r>
                     <a:rPr lang="fr-FR" dirty="0"/>
-                    <a:t> Ils sont plus âgés, mais appartiennent à un groupe à faibles revenus.</a:t>
+                    <a:t>Revenu (77 k) et dépenses (1 404) les plus élevés</a:t>
                   </a:r>
                 </a:p>
               </p:txBody>
@@ -9697,7 +9697,7 @@
           <a:p>
             <a:r>
               <a:rPr lang="fr-FR" dirty="0"/>
-              <a:t>Cluster 2 :Jeunes familles avec enfants uniques</a:t>
+              <a:t>Cluster 2 : Familles aisées sensibles aux promotions</a:t>
             </a:r>
           </a:p>
         </p:txBody>

</xml_diff>